<commit_message>
docs: update project README badges and contributor roles, and add DEXTRA showcase and deliverables documentation
</commit_message>
<xml_diff>
--- a/Deliverables/DEXTRA_Proposal.pptx
+++ b/Deliverables/DEXTRA_Proposal.pptx
@@ -1614,6 +1614,10 @@
           </a:solidFill>
           <a:ln/>
         </p:spPr>
+        <p:txBody>
+          <a:bodyPr/>
+          <a:p/>
+        </p:txBody>
       </p:sp>
       <p:sp>
         <p:nvSpPr>
@@ -1636,6 +1640,10 @@
           </a:solidFill>
           <a:ln/>
         </p:spPr>
+        <p:txBody>
+          <a:bodyPr/>
+          <a:p/>
+        </p:txBody>
       </p:sp>
       <p:sp>
         <p:nvSpPr>
@@ -1702,6 +1710,10 @@
             </a:outerShdw>
           </a:effectLst>
         </p:spPr>
+        <p:txBody>
+          <a:bodyPr/>
+          <a:p/>
+        </p:txBody>
       </p:sp>
       <p:pic>
         <p:nvPicPr>
@@ -1827,6 +1839,10 @@
             <a:prstDash val="solid"/>
           </a:ln>
         </p:spPr>
+        <p:txBody>
+          <a:bodyPr/>
+          <a:p/>
+        </p:txBody>
       </p:sp>
       <p:sp>
         <p:nvSpPr>
@@ -1853,26 +1869,7 @@
               <a:buNone/>
             </a:pPr>
             <a:r>
-              <a:rPr lang="en-US" sz="1400" b="1" dirty="0">
-                <a:solidFill>
-                  <a:srgbClr val="FFFFFF"/>
-                </a:solidFill>
-                <a:latin typeface="Calibri" pitchFamily="34" charset="0"/>
-                <a:ea typeface="Calibri" pitchFamily="34" charset="-122"/>
-                <a:cs typeface="Calibri" pitchFamily="34" charset="-120"/>
-              </a:rPr>
-              <a:t>Submitted by:  </a:t>
-            </a:r>
-            <a:r>
-              <a:rPr lang="en-US" sz="1400" dirty="0">
-                <a:solidFill>
-                  <a:srgbClr val="C9DAD8"/>
-                </a:solidFill>
-                <a:latin typeface="Calibri" pitchFamily="34" charset="0"/>
-                <a:ea typeface="Calibri" pitchFamily="34" charset="-122"/>
-                <a:cs typeface="Calibri" pitchFamily="34" charset="-120"/>
-              </a:rPr>
-              <a:t>Salman · Logesh · Muthamil · Godfrey</a:t>
+              <a:t>Ideator: Harihar R (@HARIHAR1406)  ·  Submitted by: Mohamed Salman P · Logesh M · Muthamil V · Godfrey T R</a:t>
             </a:r>
             <a:endParaRPr lang="en-US" sz="1400" dirty="0"/>
           </a:p>
@@ -1993,6 +1990,10 @@
             <a:prstDash val="solid"/>
           </a:ln>
         </p:spPr>
+        <p:txBody>
+          <a:bodyPr/>
+          <a:p/>
+        </p:txBody>
       </p:sp>
       <p:pic>
         <p:nvPicPr>
@@ -4470,6 +4471,10 @@
           </a:solidFill>
           <a:ln/>
         </p:spPr>
+        <p:txBody>
+          <a:bodyPr/>
+          <a:p/>
+        </p:txBody>
       </p:sp>
       <p:sp>
         <p:nvSpPr>
@@ -4497,6 +4502,10 @@
             </a:outerShdw>
           </a:effectLst>
         </p:spPr>
+        <p:txBody>
+          <a:bodyPr/>
+          <a:p/>
+        </p:txBody>
       </p:sp>
       <p:pic>
         <p:nvPicPr>
@@ -4625,15 +4634,7 @@
               <a:buNone/>
             </a:pPr>
             <a:r>
-              <a:rPr lang="en-US" sz="1300" dirty="0">
-                <a:solidFill>
-                  <a:srgbClr val="C9DAD8"/>
-                </a:solidFill>
-                <a:latin typeface="Calibri" pitchFamily="34" charset="0"/>
-                <a:ea typeface="Calibri" pitchFamily="34" charset="-122"/>
-                <a:cs typeface="Calibri" pitchFamily="34" charset="-120"/>
-              </a:rPr>
-              <a:t>Team: Salman · Logesh · Muthamil · Godfrey   |   Target: Windows 10/11 desktop utility   |   Start: Week 1, Foundation</a:t>
+              <a:t>Ideator: Harihar R (@HARIHAR1406)   |   Team: Mohamed Salman P · Logesh M · Muthamil V · Godfrey T R   |   Target: Windows 10/11 desktop utility</a:t>
             </a:r>
             <a:endParaRPr lang="en-US" sz="1300" dirty="0"/>
           </a:p>
@@ -4661,6 +4662,10 @@
             <a:prstDash val="solid"/>
           </a:ln>
         </p:spPr>
+        <p:txBody>
+          <a:bodyPr/>
+          <a:p/>
+        </p:txBody>
       </p:sp>
       <p:sp>
         <p:nvSpPr>
@@ -4829,6 +4834,10 @@
           </a:solidFill>
           <a:ln/>
         </p:spPr>
+        <p:txBody>
+          <a:bodyPr/>
+          <a:p/>
+        </p:txBody>
       </p:sp>
       <p:sp>
         <p:nvSpPr>
@@ -4936,15 +4945,7 @@
               <a:buNone/>
             </a:pPr>
             <a:r>
-              <a:rPr lang="en-US" sz="1500" dirty="0">
-                <a:solidFill>
-                  <a:srgbClr val="D7E4E3"/>
-                </a:solidFill>
-                <a:latin typeface="Calibri" pitchFamily="34" charset="0"/>
-                <a:ea typeface="Calibri" pitchFamily="34" charset="-122"/>
-                <a:cs typeface="Calibri" pitchFamily="34" charset="-120"/>
-              </a:rPr>
-              <a:t>Four engineers — Salman, Logesh, Muthamil, and Godfrey — have submitted DEXTRA: a proposal to replace the physical mouse with real-time hand-gesture and voice control. Before this idea reaches sanction, it must clear a structured review: problem framing, technical solution, architecture, technology choices, risk posture, and a final feasibility verdict.</a:t>
+              <a:t>Conceived by system ideator Harihar R (@HARIHAR1406) and developed by collaborators Mohamed Salman P, Logesh M, Muthamil V, and Godfrey T R, DEXTRA replaces the physical mouse with real-time hand-gesture and voice control. Before this idea reaches sanction, it must clear a structured review: problem framing, technical solution, architecture, technology choices, risk posture, and a final feasibility verdict.</a:t>
             </a:r>
             <a:endParaRPr lang="en-US" sz="1500" dirty="0"/>
           </a:p>
@@ -4976,6 +4977,10 @@
             <a:prstDash val="solid"/>
           </a:ln>
         </p:spPr>
+        <p:txBody>
+          <a:bodyPr/>
+          <a:p/>
+        </p:txBody>
       </p:sp>
       <p:pic>
         <p:nvPicPr>
@@ -5066,6 +5071,10 @@
             <a:prstDash val="solid"/>
           </a:ln>
         </p:spPr>
+        <p:txBody>
+          <a:bodyPr/>
+          <a:p/>
+        </p:txBody>
       </p:sp>
       <p:pic>
         <p:nvPicPr>
@@ -5156,6 +5165,10 @@
             <a:prstDash val="solid"/>
           </a:ln>
         </p:spPr>
+        <p:txBody>
+          <a:bodyPr/>
+          <a:p/>
+        </p:txBody>
       </p:sp>
       <p:pic>
         <p:nvPicPr>
@@ -5250,6 +5263,10 @@
             </a:outerShdw>
           </a:effectLst>
         </p:spPr>
+        <p:txBody>
+          <a:bodyPr/>
+          <a:p/>
+        </p:txBody>
       </p:sp>
       <p:sp>
         <p:nvSpPr>

</xml_diff>